<commit_message>
PPT: refresh architecture slide (fuel-anchored, three data tiers) + auto-capture slide
Co-Authored-By: Claude Fable 5 <noreply@anthropic.com>
</commit_message>
<xml_diff>
--- a/CarbonTrace_MSME_Hackathon.pptx
+++ b/CarbonTrace_MSME_Hackathon.pptx
@@ -8,6 +8,7 @@
     <p:sldId id="256" r:id="rId7"/>
     <p:sldId id="257" r:id="rId8"/>
     <p:sldId id="258" r:id="rId9"/>
+    <p:sldId id="264" r:id="rId15"/>
     <p:sldId id="259" r:id="rId10"/>
     <p:sldId id="260" r:id="rId11"/>
     <p:sldId id="261" r:id="rId12"/>
@@ -3806,7 +3807,7 @@
                 </a:solidFill>
                 <a:latin typeface="Calibri"/>
               </a:rPr>
-              <a:t>Architectural Diagram</a:t>
+              <a:t>Architecture — Fuel-Anchored, Three Data Tiers</a:t>
             </a:r>
           </a:p>
         </p:txBody>
@@ -3863,8 +3864,8 @@
         </p:nvSpPr>
         <p:spPr>
           <a:xfrm>
-            <a:off x="411480" y="1234440"/>
-            <a:ext cx="2542032" cy="411480"/>
+            <a:off x="411480" y="1115568"/>
+            <a:ext cx="2542032" cy="365760"/>
           </a:xfrm>
           <a:prstGeom prst="rect">
             <a:avLst/>
@@ -3883,7 +3884,7 @@
               </a:lnSpc>
             </a:pPr>
             <a:r>
-              <a:rPr sz="1500" b="1">
+              <a:rPr sz="1400" b="1">
                 <a:solidFill>
                   <a:srgbClr val="1B5E20"/>
                 </a:solidFill>
@@ -3902,8 +3903,8 @@
         </p:nvSpPr>
         <p:spPr>
           <a:xfrm>
-            <a:off x="411480" y="1874519"/>
-            <a:ext cx="2542032" cy="960120"/>
+            <a:off x="411480" y="1627632"/>
+            <a:ext cx="2542032" cy="804672"/>
           </a:xfrm>
           <a:prstGeom prst="roundRect">
             <a:avLst/>
@@ -3933,12 +3934,12 @@
           </a:fontRef>
         </p:style>
         <p:txBody>
-          <a:bodyPr rtlCol="0" anchor="ctr" wrap="square"/>
+          <a:bodyPr rtlCol="0" anchor="ctr" wrap="square" tIns="18000" bIns="18000"/>
           <a:lstStyle/>
           <a:p>
             <a:pPr algn="ctr"/>
             <a:r>
-              <a:rPr sz="1350" b="1">
+              <a:rPr sz="1200" b="1">
                 <a:solidFill>
                   <a:srgbClr val="212121"/>
                 </a:solidFill>
@@ -3950,13 +3951,13 @@
           <a:p>
             <a:pPr algn="ctr"/>
             <a:r>
-              <a:rPr sz="1350" b="0">
+              <a:rPr sz="1200" b="0">
                 <a:solidFill>
                   <a:srgbClr val="212121"/>
                 </a:solidFill>
                 <a:latin typeface="Calibri"/>
               </a:rPr>
-              <a:t>(ignition / trip trigger)</a:t>
+              <a:t>(auto-start trigger)</a:t>
             </a:r>
           </a:p>
         </p:txBody>
@@ -3969,8 +3970,8 @@
         </p:nvSpPr>
         <p:spPr>
           <a:xfrm>
-            <a:off x="411480" y="3090671"/>
-            <a:ext cx="2542032" cy="960120"/>
+            <a:off x="411480" y="2596896"/>
+            <a:ext cx="2542032" cy="804672"/>
           </a:xfrm>
           <a:prstGeom prst="roundRect">
             <a:avLst/>
@@ -4000,12 +4001,12 @@
           </a:fontRef>
         </p:style>
         <p:txBody>
-          <a:bodyPr rtlCol="0" anchor="ctr" wrap="square"/>
+          <a:bodyPr rtlCol="0" anchor="ctr" wrap="square" tIns="18000" bIns="18000"/>
           <a:lstStyle/>
           <a:p>
             <a:pPr algn="ctr"/>
             <a:r>
-              <a:rPr sz="1350" b="1">
+              <a:rPr sz="1200" b="1">
                 <a:solidFill>
                   <a:srgbClr val="212121"/>
                 </a:solidFill>
@@ -4017,13 +4018,13 @@
           <a:p>
             <a:pPr algn="ctr"/>
             <a:r>
-              <a:rPr sz="1350" b="0">
+              <a:rPr sz="1200" b="0">
                 <a:solidFill>
                   <a:srgbClr val="212121"/>
                 </a:solidFill>
                 <a:latin typeface="Calibri"/>
               </a:rPr>
-              <a:t>sensors (drive data)</a:t>
+              <a:t>(drive profile)</a:t>
             </a:r>
           </a:p>
         </p:txBody>
@@ -4036,8 +4037,8 @@
         </p:nvSpPr>
         <p:spPr>
           <a:xfrm>
-            <a:off x="411480" y="4306823"/>
-            <a:ext cx="2542032" cy="960120"/>
+            <a:off x="411480" y="3566160"/>
+            <a:ext cx="2542032" cy="804672"/>
           </a:xfrm>
           <a:prstGeom prst="roundRect">
             <a:avLst/>
@@ -4067,44 +4068,111 @@
           </a:fontRef>
         </p:style>
         <p:txBody>
-          <a:bodyPr rtlCol="0" anchor="ctr" wrap="square"/>
+          <a:bodyPr rtlCol="0" anchor="ctr" wrap="square" tIns="18000" bIns="18000"/>
           <a:lstStyle/>
           <a:p>
             <a:pPr algn="ctr"/>
             <a:r>
-              <a:rPr sz="1350" b="1">
+              <a:rPr sz="1200" b="1">
                 <a:solidFill>
                   <a:srgbClr val="212121"/>
                 </a:solidFill>
                 <a:latin typeface="Calibri"/>
               </a:rPr>
-              <a:t>Connected-car API</a:t>
+              <a:t>Payment notifications</a:t>
             </a:r>
           </a:p>
           <a:p>
             <a:pPr algn="ctr"/>
             <a:r>
-              <a:rPr sz="1350" b="0">
+              <a:rPr sz="1200" b="0">
                 <a:solidFill>
                   <a:srgbClr val="212121"/>
                 </a:solidFill>
                 <a:latin typeface="Calibri"/>
               </a:rPr>
-              <a:t>(optional, fuel data)</a:t>
-            </a:r>
-          </a:p>
-        </p:txBody>
-      </p:sp>
-      <p:sp>
-        <p:nvSpPr>
-          <p:cNvPr id="9" name="TextBox 8"/>
+              <a:t>(litres, on-device)</a:t>
+            </a:r>
+          </a:p>
+        </p:txBody>
+      </p:sp>
+      <p:sp>
+        <p:nvSpPr>
+          <p:cNvPr id="9" name="Rounded Rectangle 8"/>
+          <p:cNvSpPr/>
+          <p:nvPr/>
+        </p:nvSpPr>
+        <p:spPr>
+          <a:xfrm>
+            <a:off x="411480" y="4535424"/>
+            <a:ext cx="2542032" cy="804672"/>
+          </a:xfrm>
+          <a:prstGeom prst="roundRect">
+            <a:avLst/>
+          </a:prstGeom>
+          <a:solidFill>
+            <a:srgbClr val="F1F8E9"/>
+          </a:solidFill>
+          <a:ln w="12700">
+            <a:solidFill>
+              <a:srgbClr val="43A047"/>
+            </a:solidFill>
+          </a:ln>
+          <a:effectLst/>
+        </p:spPr>
+        <p:style>
+          <a:lnRef idx="1">
+            <a:schemeClr val="accent1"/>
+          </a:lnRef>
+          <a:fillRef idx="3">
+            <a:schemeClr val="accent1"/>
+          </a:fillRef>
+          <a:effectRef idx="2">
+            <a:schemeClr val="accent1"/>
+          </a:effectRef>
+          <a:fontRef idx="minor">
+            <a:schemeClr val="lt1"/>
+          </a:fontRef>
+        </p:style>
+        <p:txBody>
+          <a:bodyPr rtlCol="0" anchor="ctr" wrap="square" tIns="18000" bIns="18000"/>
+          <a:lstStyle/>
+          <a:p>
+            <a:pPr algn="ctr"/>
+            <a:r>
+              <a:rPr sz="1200" b="1">
+                <a:solidFill>
+                  <a:srgbClr val="212121"/>
+                </a:solidFill>
+                <a:latin typeface="Calibri"/>
+              </a:rPr>
+              <a:t>Connected-car cloud /</a:t>
+            </a:r>
+          </a:p>
+          <a:p>
+            <a:pPr algn="ctr"/>
+            <a:r>
+              <a:rPr sz="1200" b="0">
+                <a:solidFill>
+                  <a:srgbClr val="212121"/>
+                </a:solidFill>
+                <a:latin typeface="Calibri"/>
+              </a:rPr>
+              <a:t>OBD ECU (optional)</a:t>
+            </a:r>
+          </a:p>
+        </p:txBody>
+      </p:sp>
+      <p:sp>
+        <p:nvSpPr>
+          <p:cNvPr id="10" name="TextBox 9"/>
           <p:cNvSpPr txBox="1"/>
           <p:nvPr/>
         </p:nvSpPr>
         <p:spPr>
           <a:xfrm>
-            <a:off x="3429000" y="1234440"/>
-            <a:ext cx="2542032" cy="411480"/>
+            <a:off x="3429000" y="1115568"/>
+            <a:ext cx="2542032" cy="365760"/>
           </a:xfrm>
           <a:prstGeom prst="rect">
             <a:avLst/>
@@ -4123,7 +4191,7 @@
               </a:lnSpc>
             </a:pPr>
             <a:r>
-              <a:rPr sz="1500" b="1">
+              <a:rPr sz="1400" b="1">
                 <a:solidFill>
                   <a:srgbClr val="1B5E20"/>
                 </a:solidFill>
@@ -4136,14 +4204,14 @@
       </p:sp>
       <p:sp>
         <p:nvSpPr>
-          <p:cNvPr id="10" name="Rounded Rectangle 9"/>
+          <p:cNvPr id="11" name="Rounded Rectangle 10"/>
           <p:cNvSpPr/>
           <p:nvPr/>
         </p:nvSpPr>
         <p:spPr>
           <a:xfrm>
-            <a:off x="3429000" y="1874519"/>
-            <a:ext cx="2542032" cy="960120"/>
+            <a:off x="3429000" y="1627632"/>
+            <a:ext cx="2542032" cy="804672"/>
           </a:xfrm>
           <a:prstGeom prst="roundRect">
             <a:avLst/>
@@ -4173,44 +4241,44 @@
           </a:fontRef>
         </p:style>
         <p:txBody>
-          <a:bodyPr rtlCol="0" anchor="ctr" wrap="square"/>
+          <a:bodyPr rtlCol="0" anchor="ctr" wrap="square" tIns="18000" bIns="18000"/>
           <a:lstStyle/>
           <a:p>
             <a:pPr algn="ctr"/>
             <a:r>
-              <a:rPr sz="1350" b="1">
+              <a:rPr sz="1200" b="1">
                 <a:solidFill>
                   <a:srgbClr val="212121"/>
                 </a:solidFill>
                 <a:latin typeface="Calibri"/>
               </a:rPr>
-              <a:t>Auto-start trip</a:t>
+              <a:t>Auto trip recorder</a:t>
             </a:r>
           </a:p>
           <a:p>
             <a:pPr algn="ctr"/>
             <a:r>
-              <a:rPr sz="1350" b="0">
+              <a:rPr sz="1200" b="0">
                 <a:solidFill>
                   <a:srgbClr val="212121"/>
                 </a:solidFill>
                 <a:latin typeface="Calibri"/>
               </a:rPr>
-              <a:t>recorder service</a:t>
-            </a:r>
-          </a:p>
-        </p:txBody>
-      </p:sp>
-      <p:sp>
-        <p:nvSpPr>
-          <p:cNvPr id="11" name="Rounded Rectangle 10"/>
+              <a:t>(zero-touch)</a:t>
+            </a:r>
+          </a:p>
+        </p:txBody>
+      </p:sp>
+      <p:sp>
+        <p:nvSpPr>
+          <p:cNvPr id="12" name="Rounded Rectangle 11"/>
           <p:cNvSpPr/>
           <p:nvPr/>
         </p:nvSpPr>
         <p:spPr>
           <a:xfrm>
-            <a:off x="3429000" y="3090671"/>
-            <a:ext cx="2542032" cy="960120"/>
+            <a:off x="3429000" y="2596896"/>
+            <a:ext cx="2542032" cy="804672"/>
           </a:xfrm>
           <a:prstGeom prst="roundRect">
             <a:avLst/>
@@ -4240,44 +4308,44 @@
           </a:fontRef>
         </p:style>
         <p:txBody>
-          <a:bodyPr rtlCol="0" anchor="ctr" wrap="square"/>
+          <a:bodyPr rtlCol="0" anchor="ctr" wrap="square" tIns="18000" bIns="18000"/>
           <a:lstStyle/>
           <a:p>
             <a:pPr algn="ctr"/>
             <a:r>
-              <a:rPr sz="1350" b="1">
+              <a:rPr sz="1200" b="1">
                 <a:solidFill>
                   <a:srgbClr val="212121"/>
                 </a:solidFill>
                 <a:latin typeface="Calibri"/>
               </a:rPr>
-              <a:t>Local trip store</a:t>
+              <a:t>Virtual odometer</a:t>
             </a:r>
           </a:p>
           <a:p>
             <a:pPr algn="ctr"/>
             <a:r>
-              <a:rPr sz="1350" b="0">
+              <a:rPr sz="1200" b="0">
                 <a:solidFill>
                   <a:srgbClr val="212121"/>
                 </a:solidFill>
                 <a:latin typeface="Calibri"/>
               </a:rPr>
-              <a:t>(offline-first)</a:t>
-            </a:r>
-          </a:p>
-        </p:txBody>
-      </p:sp>
-      <p:sp>
-        <p:nvSpPr>
-          <p:cNvPr id="12" name="Rounded Rectangle 11"/>
+              <a:t>(auto-advancing)</a:t>
+            </a:r>
+          </a:p>
+        </p:txBody>
+      </p:sp>
+      <p:sp>
+        <p:nvSpPr>
+          <p:cNvPr id="13" name="Rounded Rectangle 12"/>
           <p:cNvSpPr/>
           <p:nvPr/>
         </p:nvSpPr>
         <p:spPr>
           <a:xfrm>
-            <a:off x="3429000" y="4306823"/>
-            <a:ext cx="2542032" cy="960120"/>
+            <a:off x="3429000" y="3566160"/>
+            <a:ext cx="2542032" cy="804672"/>
           </a:xfrm>
           <a:prstGeom prst="roundRect">
             <a:avLst/>
@@ -4307,69 +4375,30 @@
           </a:fontRef>
         </p:style>
         <p:txBody>
-          <a:bodyPr rtlCol="0" anchor="ctr" wrap="square"/>
+          <a:bodyPr rtlCol="0" anchor="ctr" wrap="square" tIns="18000" bIns="18000"/>
           <a:lstStyle/>
           <a:p>
             <a:pPr algn="ctr"/>
             <a:r>
-              <a:rPr sz="1350" b="1">
+              <a:rPr sz="1200" b="1">
                 <a:solidFill>
                   <a:srgbClr val="212121"/>
                 </a:solidFill>
                 <a:latin typeface="Calibri"/>
               </a:rPr>
-              <a:t>Dashboard and</a:t>
+              <a:t>Auto fill-up capture</a:t>
             </a:r>
           </a:p>
           <a:p>
             <a:pPr algn="ctr"/>
             <a:r>
-              <a:rPr sz="1350" b="0">
+              <a:rPr sz="1200" b="0">
                 <a:solidFill>
                   <a:srgbClr val="212121"/>
                 </a:solidFill>
                 <a:latin typeface="Calibri"/>
               </a:rPr>
-              <a:t>alerts UI</a:t>
-            </a:r>
-          </a:p>
-        </p:txBody>
-      </p:sp>
-      <p:sp>
-        <p:nvSpPr>
-          <p:cNvPr id="13" name="TextBox 12"/>
-          <p:cNvSpPr txBox="1"/>
-          <p:nvPr/>
-        </p:nvSpPr>
-        <p:spPr>
-          <a:xfrm>
-            <a:off x="6446520" y="1234440"/>
-            <a:ext cx="2542032" cy="411480"/>
-          </a:xfrm>
-          <a:prstGeom prst="rect">
-            <a:avLst/>
-          </a:prstGeom>
-          <a:noFill/>
-        </p:spPr>
-        <p:txBody>
-          <a:bodyPr wrap="square" anchor="t">
-            <a:spAutoFit/>
-          </a:bodyPr>
-          <a:lstStyle/>
-          <a:p>
-            <a:pPr algn="ctr">
-              <a:lnSpc>
-                <a:spcPct val="100000"/>
-              </a:lnSpc>
-            </a:pPr>
-            <a:r>
-              <a:rPr sz="1500" b="1">
-                <a:solidFill>
-                  <a:srgbClr val="1B5E20"/>
-                </a:solidFill>
-                <a:latin typeface="Calibri"/>
-              </a:rPr>
-              <a:t>3. CLOUD BACKEND</a:t>
+              <a:t>(refuel stop + payment)</a:t>
             </a:r>
           </a:p>
         </p:txBody>
@@ -4382,8 +4411,8 @@
         </p:nvSpPr>
         <p:spPr>
           <a:xfrm>
-            <a:off x="6446520" y="1874519"/>
-            <a:ext cx="2542032" cy="960120"/>
+            <a:off x="3429000" y="4535424"/>
+            <a:ext cx="2542032" cy="804672"/>
           </a:xfrm>
           <a:prstGeom prst="roundRect">
             <a:avLst/>
@@ -4413,44 +4442,83 @@
           </a:fontRef>
         </p:style>
         <p:txBody>
-          <a:bodyPr rtlCol="0" anchor="ctr" wrap="square"/>
+          <a:bodyPr rtlCol="0" anchor="ctr" wrap="square" tIns="18000" bIns="18000"/>
           <a:lstStyle/>
           <a:p>
             <a:pPr algn="ctr"/>
             <a:r>
-              <a:rPr sz="1350" b="1">
+              <a:rPr sz="1200" b="1">
                 <a:solidFill>
                   <a:srgbClr val="212121"/>
                 </a:solidFill>
                 <a:latin typeface="Calibri"/>
               </a:rPr>
-              <a:t>Emission estimation</a:t>
+              <a:t>Offline-first store</a:t>
             </a:r>
           </a:p>
           <a:p>
             <a:pPr algn="ctr"/>
             <a:r>
-              <a:rPr sz="1350" b="0">
+              <a:rPr sz="1200" b="0">
                 <a:solidFill>
                   <a:srgbClr val="212121"/>
                 </a:solidFill>
                 <a:latin typeface="Calibri"/>
               </a:rPr>
-              <a:t>engine (BS6 / COPERT)</a:t>
-            </a:r>
-          </a:p>
-        </p:txBody>
-      </p:sp>
-      <p:sp>
-        <p:nvSpPr>
-          <p:cNvPr id="15" name="Rounded Rectangle 14"/>
+              <a:t>and dashboard</a:t>
+            </a:r>
+          </a:p>
+        </p:txBody>
+      </p:sp>
+      <p:sp>
+        <p:nvSpPr>
+          <p:cNvPr id="15" name="TextBox 14"/>
+          <p:cNvSpPr txBox="1"/>
+          <p:nvPr/>
+        </p:nvSpPr>
+        <p:spPr>
+          <a:xfrm>
+            <a:off x="6446520" y="1115568"/>
+            <a:ext cx="2542032" cy="365760"/>
+          </a:xfrm>
+          <a:prstGeom prst="rect">
+            <a:avLst/>
+          </a:prstGeom>
+          <a:noFill/>
+        </p:spPr>
+        <p:txBody>
+          <a:bodyPr wrap="square" anchor="t">
+            <a:spAutoFit/>
+          </a:bodyPr>
+          <a:lstStyle/>
+          <a:p>
+            <a:pPr algn="ctr">
+              <a:lnSpc>
+                <a:spcPct val="100000"/>
+              </a:lnSpc>
+            </a:pPr>
+            <a:r>
+              <a:rPr sz="1400" b="1">
+                <a:solidFill>
+                  <a:srgbClr val="1B5E20"/>
+                </a:solidFill>
+                <a:latin typeface="Calibri"/>
+              </a:rPr>
+              <a:t>3. CLOUD BACKEND</a:t>
+            </a:r>
+          </a:p>
+        </p:txBody>
+      </p:sp>
+      <p:sp>
+        <p:nvSpPr>
+          <p:cNvPr id="16" name="Rounded Rectangle 15"/>
           <p:cNvSpPr/>
           <p:nvPr/>
         </p:nvSpPr>
         <p:spPr>
           <a:xfrm>
-            <a:off x="6446520" y="3090671"/>
-            <a:ext cx="2542032" cy="960120"/>
+            <a:off x="6446520" y="1627632"/>
+            <a:ext cx="2542032" cy="804672"/>
           </a:xfrm>
           <a:prstGeom prst="roundRect">
             <a:avLst/>
@@ -4480,44 +4548,44 @@
           </a:fontRef>
         </p:style>
         <p:txBody>
-          <a:bodyPr rtlCol="0" anchor="ctr" wrap="square"/>
+          <a:bodyPr rtlCol="0" anchor="ctr" wrap="square" tIns="18000" bIns="18000"/>
           <a:lstStyle/>
           <a:p>
             <a:pPr algn="ctr"/>
             <a:r>
-              <a:rPr sz="1350" b="1">
+              <a:rPr sz="1200" b="1">
                 <a:solidFill>
                   <a:srgbClr val="212121"/>
                 </a:solidFill>
                 <a:latin typeface="Calibri"/>
               </a:rPr>
-              <a:t>Anomaly detection</a:t>
+              <a:t>Emission engine</a:t>
             </a:r>
           </a:p>
           <a:p>
             <a:pPr algn="ctr"/>
             <a:r>
-              <a:rPr sz="1350" b="0">
+              <a:rPr sz="1200" b="0">
                 <a:solidFill>
                   <a:srgbClr val="212121"/>
                 </a:solidFill>
                 <a:latin typeface="Calibri"/>
               </a:rPr>
-              <a:t>(baseline drift)</a:t>
-            </a:r>
-          </a:p>
-        </p:txBody>
-      </p:sp>
-      <p:sp>
-        <p:nvSpPr>
-          <p:cNvPr id="16" name="Rounded Rectangle 15"/>
+              <a:t>(COPERT/BS6 + fuel chemistry)</a:t>
+            </a:r>
+          </a:p>
+        </p:txBody>
+      </p:sp>
+      <p:sp>
+        <p:nvSpPr>
+          <p:cNvPr id="17" name="Rounded Rectangle 16"/>
           <p:cNvSpPr/>
           <p:nvPr/>
         </p:nvSpPr>
         <p:spPr>
           <a:xfrm>
-            <a:off x="6446520" y="4306823"/>
-            <a:ext cx="2542032" cy="960120"/>
+            <a:off x="6446520" y="2596896"/>
+            <a:ext cx="2542032" cy="804672"/>
           </a:xfrm>
           <a:prstGeom prst="roundRect">
             <a:avLst/>
@@ -4547,44 +4615,178 @@
           </a:fontRef>
         </p:style>
         <p:txBody>
-          <a:bodyPr rtlCol="0" anchor="ctr" wrap="square"/>
+          <a:bodyPr rtlCol="0" anchor="ctr" wrap="square" tIns="18000" bIns="18000"/>
           <a:lstStyle/>
           <a:p>
             <a:pPr algn="ctr"/>
             <a:r>
-              <a:rPr sz="1350" b="1">
+              <a:rPr sz="1200" b="1">
                 <a:solidFill>
                   <a:srgbClr val="212121"/>
                 </a:solidFill>
                 <a:latin typeface="Calibri"/>
               </a:rPr>
-              <a:t>Trip and vehicle</a:t>
+              <a:t>Calibration</a:t>
             </a:r>
           </a:p>
           <a:p>
             <a:pPr algn="ctr"/>
             <a:r>
-              <a:rPr sz="1350" b="0">
+              <a:rPr sz="1200" b="0">
                 <a:solidFill>
                   <a:srgbClr val="212121"/>
                 </a:solidFill>
                 <a:latin typeface="Calibri"/>
               </a:rPr>
-              <a:t>database</a:t>
-            </a:r>
-          </a:p>
-        </p:txBody>
-      </p:sp>
-      <p:sp>
-        <p:nvSpPr>
-          <p:cNvPr id="17" name="TextBox 16"/>
+              <a:t>(measured / modelled)</a:t>
+            </a:r>
+          </a:p>
+        </p:txBody>
+      </p:sp>
+      <p:sp>
+        <p:nvSpPr>
+          <p:cNvPr id="18" name="Rounded Rectangle 17"/>
+          <p:cNvSpPr/>
+          <p:nvPr/>
+        </p:nvSpPr>
+        <p:spPr>
+          <a:xfrm>
+            <a:off x="6446520" y="3566160"/>
+            <a:ext cx="2542032" cy="804672"/>
+          </a:xfrm>
+          <a:prstGeom prst="roundRect">
+            <a:avLst/>
+          </a:prstGeom>
+          <a:solidFill>
+            <a:srgbClr val="FFFFFF"/>
+          </a:solidFill>
+          <a:ln w="12700">
+            <a:solidFill>
+              <a:srgbClr val="43A047"/>
+            </a:solidFill>
+          </a:ln>
+          <a:effectLst/>
+        </p:spPr>
+        <p:style>
+          <a:lnRef idx="1">
+            <a:schemeClr val="accent1"/>
+          </a:lnRef>
+          <a:fillRef idx="3">
+            <a:schemeClr val="accent1"/>
+          </a:fillRef>
+          <a:effectRef idx="2">
+            <a:schemeClr val="accent1"/>
+          </a:effectRef>
+          <a:fontRef idx="minor">
+            <a:schemeClr val="lt1"/>
+          </a:fontRef>
+        </p:style>
+        <p:txBody>
+          <a:bodyPr rtlCol="0" anchor="ctr" wrap="square" tIns="18000" bIns="18000"/>
+          <a:lstStyle/>
+          <a:p>
+            <a:pPr algn="ctr"/>
+            <a:r>
+              <a:rPr sz="1200" b="1">
+                <a:solidFill>
+                  <a:srgbClr val="212121"/>
+                </a:solidFill>
+                <a:latin typeface="Calibri"/>
+              </a:rPr>
+              <a:t>Baseline per driving type</a:t>
+            </a:r>
+          </a:p>
+          <a:p>
+            <a:pPr algn="ctr"/>
+            <a:r>
+              <a:rPr sz="1200" b="0">
+                <a:solidFill>
+                  <a:srgbClr val="212121"/>
+                </a:solidFill>
+                <a:latin typeface="Calibri"/>
+              </a:rPr>
+              <a:t>(city / mixed / highway)</a:t>
+            </a:r>
+          </a:p>
+        </p:txBody>
+      </p:sp>
+      <p:sp>
+        <p:nvSpPr>
+          <p:cNvPr id="19" name="Rounded Rectangle 18"/>
+          <p:cNvSpPr/>
+          <p:nvPr/>
+        </p:nvSpPr>
+        <p:spPr>
+          <a:xfrm>
+            <a:off x="6446520" y="4535424"/>
+            <a:ext cx="2542032" cy="804672"/>
+          </a:xfrm>
+          <a:prstGeom prst="roundRect">
+            <a:avLst/>
+          </a:prstGeom>
+          <a:solidFill>
+            <a:srgbClr val="FFFFFF"/>
+          </a:solidFill>
+          <a:ln w="12700">
+            <a:solidFill>
+              <a:srgbClr val="43A047"/>
+            </a:solidFill>
+          </a:ln>
+          <a:effectLst/>
+        </p:spPr>
+        <p:style>
+          <a:lnRef idx="1">
+            <a:schemeClr val="accent1"/>
+          </a:lnRef>
+          <a:fillRef idx="3">
+            <a:schemeClr val="accent1"/>
+          </a:fillRef>
+          <a:effectRef idx="2">
+            <a:schemeClr val="accent1"/>
+          </a:effectRef>
+          <a:fontRef idx="minor">
+            <a:schemeClr val="lt1"/>
+          </a:fontRef>
+        </p:style>
+        <p:txBody>
+          <a:bodyPr rtlCol="0" anchor="ctr" wrap="square" tIns="18000" bIns="18000"/>
+          <a:lstStyle/>
+          <a:p>
+            <a:pPr algn="ctr"/>
+            <a:r>
+              <a:rPr sz="1200" b="1">
+                <a:solidFill>
+                  <a:srgbClr val="212121"/>
+                </a:solidFill>
+                <a:latin typeface="Calibri"/>
+              </a:rPr>
+              <a:t>EWMA drift detection</a:t>
+            </a:r>
+          </a:p>
+          <a:p>
+            <a:pPr algn="ctr"/>
+            <a:r>
+              <a:rPr sz="1200" b="0">
+                <a:solidFill>
+                  <a:srgbClr val="212121"/>
+                </a:solidFill>
+                <a:latin typeface="Calibri"/>
+              </a:rPr>
+              <a:t>(alerts, PUC risk)</a:t>
+            </a:r>
+          </a:p>
+        </p:txBody>
+      </p:sp>
+      <p:sp>
+        <p:nvSpPr>
+          <p:cNvPr id="20" name="TextBox 19"/>
           <p:cNvSpPr txBox="1"/>
           <p:nvPr/>
         </p:nvSpPr>
         <p:spPr>
           <a:xfrm>
-            <a:off x="9464040" y="1234440"/>
-            <a:ext cx="2542032" cy="411480"/>
+            <a:off x="9464040" y="1115568"/>
+            <a:ext cx="2542032" cy="365760"/>
           </a:xfrm>
           <a:prstGeom prst="rect">
             <a:avLst/>
@@ -4603,7 +4805,7 @@
               </a:lnSpc>
             </a:pPr>
             <a:r>
-              <a:rPr sz="1500" b="1">
+              <a:rPr sz="1400" b="1">
                 <a:solidFill>
                   <a:srgbClr val="1B5E20"/>
                 </a:solidFill>
@@ -4616,14 +4818,14 @@
       </p:sp>
       <p:sp>
         <p:nvSpPr>
-          <p:cNvPr id="18" name="Rounded Rectangle 17"/>
+          <p:cNvPr id="21" name="Rounded Rectangle 20"/>
           <p:cNvSpPr/>
           <p:nvPr/>
         </p:nvSpPr>
         <p:spPr>
           <a:xfrm>
-            <a:off x="9464040" y="1874519"/>
-            <a:ext cx="2542032" cy="960120"/>
+            <a:off x="9464040" y="1627632"/>
+            <a:ext cx="2542032" cy="804672"/>
           </a:xfrm>
           <a:prstGeom prst="roundRect">
             <a:avLst/>
@@ -4653,44 +4855,44 @@
           </a:fontRef>
         </p:style>
         <p:txBody>
-          <a:bodyPr rtlCol="0" anchor="ctr" wrap="square"/>
+          <a:bodyPr rtlCol="0" anchor="ctr" wrap="square" tIns="18000" bIns="18000"/>
           <a:lstStyle/>
           <a:p>
             <a:pPr algn="ctr"/>
             <a:r>
-              <a:rPr sz="1350" b="1">
+              <a:rPr sz="1200" b="1">
                 <a:solidFill>
                   <a:srgbClr val="212121"/>
                 </a:solidFill>
                 <a:latin typeface="Calibri"/>
               </a:rPr>
-              <a:t>CO2 per trip and</a:t>
+              <a:t>Trip CO2 records</a:t>
             </a:r>
           </a:p>
           <a:p>
             <a:pPr algn="ctr"/>
             <a:r>
-              <a:rPr sz="1350" b="0">
+              <a:rPr sz="1200" b="0">
                 <a:solidFill>
                   <a:srgbClr val="212121"/>
                 </a:solidFill>
                 <a:latin typeface="Calibri"/>
               </a:rPr>
-              <a:t>g/km trends</a:t>
-            </a:r>
-          </a:p>
-        </p:txBody>
-      </p:sp>
-      <p:sp>
-        <p:nvSpPr>
-          <p:cNvPr id="19" name="Rounded Rectangle 18"/>
+              <a:t>and g/km trends</a:t>
+            </a:r>
+          </a:p>
+        </p:txBody>
+      </p:sp>
+      <p:sp>
+        <p:nvSpPr>
+          <p:cNvPr id="22" name="Rounded Rectangle 21"/>
           <p:cNvSpPr/>
           <p:nvPr/>
         </p:nvSpPr>
         <p:spPr>
           <a:xfrm>
-            <a:off x="9464040" y="3090671"/>
-            <a:ext cx="2542032" cy="960120"/>
+            <a:off x="9464040" y="2596896"/>
+            <a:ext cx="2542032" cy="804672"/>
           </a:xfrm>
           <a:prstGeom prst="roundRect">
             <a:avLst/>
@@ -4720,44 +4922,44 @@
           </a:fontRef>
         </p:style>
         <p:txBody>
-          <a:bodyPr rtlCol="0" anchor="ctr" wrap="square"/>
+          <a:bodyPr rtlCol="0" anchor="ctr" wrap="square" tIns="18000" bIns="18000"/>
           <a:lstStyle/>
           <a:p>
             <a:pPr algn="ctr"/>
             <a:r>
-              <a:rPr sz="1350" b="1">
+              <a:rPr sz="1200" b="1">
                 <a:solidFill>
                   <a:srgbClr val="212121"/>
                 </a:solidFill>
                 <a:latin typeface="Calibri"/>
               </a:rPr>
-              <a:t>Abnormal-emission alert</a:t>
+              <a:t>Measured fuel economy</a:t>
             </a:r>
           </a:p>
           <a:p>
             <a:pPr algn="ctr"/>
             <a:r>
-              <a:rPr sz="1350" b="0">
+              <a:rPr sz="1200" b="0">
                 <a:solidFill>
                   <a:srgbClr val="212121"/>
                 </a:solidFill>
                 <a:latin typeface="Calibri"/>
               </a:rPr>
-              <a:t>service reminder</a:t>
-            </a:r>
-          </a:p>
-        </p:txBody>
-      </p:sp>
-      <p:sp>
-        <p:nvSpPr>
-          <p:cNvPr id="20" name="Rounded Rectangle 19"/>
+              <a:t>(tank-to-tank)</a:t>
+            </a:r>
+          </a:p>
+        </p:txBody>
+      </p:sp>
+      <p:sp>
+        <p:nvSpPr>
+          <p:cNvPr id="23" name="Rounded Rectangle 22"/>
           <p:cNvSpPr/>
           <p:nvPr/>
         </p:nvSpPr>
         <p:spPr>
           <a:xfrm>
-            <a:off x="9464040" y="4306823"/>
-            <a:ext cx="2542032" cy="960120"/>
+            <a:off x="9464040" y="3566160"/>
+            <a:ext cx="2542032" cy="804672"/>
           </a:xfrm>
           <a:prstGeom prst="roundRect">
             <a:avLst/>
@@ -4787,44 +4989,111 @@
           </a:fontRef>
         </p:style>
         <p:txBody>
-          <a:bodyPr rtlCol="0" anchor="ctr" wrap="square"/>
+          <a:bodyPr rtlCol="0" anchor="ctr" wrap="square" tIns="18000" bIns="18000"/>
           <a:lstStyle/>
           <a:p>
             <a:pPr algn="ctr"/>
             <a:r>
-              <a:rPr sz="1350" b="1">
+              <a:rPr sz="1200" b="1">
                 <a:solidFill>
                   <a:srgbClr val="212121"/>
                 </a:solidFill>
                 <a:latin typeface="Calibri"/>
               </a:rPr>
+              <a:t>Service alert and</a:t>
+            </a:r>
+          </a:p>
+          <a:p>
+            <a:pPr algn="ctr"/>
+            <a:r>
+              <a:rPr sz="1200" b="0">
+                <a:solidFill>
+                  <a:srgbClr val="212121"/>
+                </a:solidFill>
+                <a:latin typeface="Calibri"/>
+              </a:rPr>
+              <a:t>recovery verification</a:t>
+            </a:r>
+          </a:p>
+        </p:txBody>
+      </p:sp>
+      <p:sp>
+        <p:nvSpPr>
+          <p:cNvPr id="24" name="Rounded Rectangle 23"/>
+          <p:cNvSpPr/>
+          <p:nvPr/>
+        </p:nvSpPr>
+        <p:spPr>
+          <a:xfrm>
+            <a:off x="9464040" y="4535424"/>
+            <a:ext cx="2542032" cy="804672"/>
+          </a:xfrm>
+          <a:prstGeom prst="roundRect">
+            <a:avLst/>
+          </a:prstGeom>
+          <a:solidFill>
+            <a:srgbClr val="F1F8E9"/>
+          </a:solidFill>
+          <a:ln w="12700">
+            <a:solidFill>
+              <a:srgbClr val="43A047"/>
+            </a:solidFill>
+          </a:ln>
+          <a:effectLst/>
+        </p:spPr>
+        <p:style>
+          <a:lnRef idx="1">
+            <a:schemeClr val="accent1"/>
+          </a:lnRef>
+          <a:fillRef idx="3">
+            <a:schemeClr val="accent1"/>
+          </a:fillRef>
+          <a:effectRef idx="2">
+            <a:schemeClr val="accent1"/>
+          </a:effectRef>
+          <a:fontRef idx="minor">
+            <a:schemeClr val="lt1"/>
+          </a:fontRef>
+        </p:style>
+        <p:txBody>
+          <a:bodyPr rtlCol="0" anchor="ctr" wrap="square" tIns="18000" bIns="18000"/>
+          <a:lstStyle/>
+          <a:p>
+            <a:pPr algn="ctr"/>
+            <a:r>
+              <a:rPr sz="1200" b="1">
+                <a:solidFill>
+                  <a:srgbClr val="212121"/>
+                </a:solidFill>
+                <a:latin typeface="Calibri"/>
+              </a:rPr>
               <a:t>PUC failure risk</a:t>
             </a:r>
           </a:p>
           <a:p>
             <a:pPr algn="ctr"/>
             <a:r>
-              <a:rPr sz="1350" b="0">
+              <a:rPr sz="1200" b="0">
                 <a:solidFill>
                   <a:srgbClr val="212121"/>
                 </a:solidFill>
                 <a:latin typeface="Calibri"/>
               </a:rPr>
-              <a:t>prediction</a:t>
+              <a:t>and fleet reports</a:t>
             </a:r>
           </a:p>
         </p:txBody>
       </p:sp>
       <p:cxnSp>
         <p:nvCxnSpPr>
-          <p:cNvPr id="21" name="Connector 20"/>
+          <p:cNvPr id="25" name="Connector 24"/>
           <p:cNvCxnSpPr/>
           <p:nvPr/>
         </p:nvCxnSpPr>
         <p:spPr>
           <a:xfrm>
-            <a:off x="2983512" y="3570731.0"/>
-            <a:ext cx="415488" cy="0.0"/>
+            <a:off x="2978512" y="3483864.0"/>
+            <a:ext cx="425488" cy="0.0"/>
           </a:xfrm>
           <a:prstGeom prst="line">
             <a:avLst/>
@@ -4853,14 +5122,14 @@
       </p:cxnSp>
       <p:cxnSp>
         <p:nvCxnSpPr>
-          <p:cNvPr id="22" name="Connector 21"/>
+          <p:cNvPr id="26" name="Connector 25"/>
           <p:cNvCxnSpPr/>
           <p:nvPr/>
         </p:nvCxnSpPr>
         <p:spPr>
           <a:xfrm>
-            <a:off x="6001032" y="3570731.0"/>
-            <a:ext cx="415488" cy="0.0"/>
+            <a:off x="5996032" y="3483864.0"/>
+            <a:ext cx="425488" cy="0.0"/>
           </a:xfrm>
           <a:prstGeom prst="line">
             <a:avLst/>
@@ -4889,14 +5158,14 @@
       </p:cxnSp>
       <p:cxnSp>
         <p:nvCxnSpPr>
-          <p:cNvPr id="23" name="Connector 22"/>
+          <p:cNvPr id="27" name="Connector 26"/>
           <p:cNvCxnSpPr/>
           <p:nvPr/>
         </p:nvCxnSpPr>
         <p:spPr>
           <a:xfrm>
-            <a:off x="9018552" y="3570731.0"/>
-            <a:ext cx="415488" cy="0.0"/>
+            <a:off x="9013552" y="3483864.0"/>
+            <a:ext cx="425488" cy="0.0"/>
           </a:xfrm>
           <a:prstGeom prst="line">
             <a:avLst/>
@@ -4925,14 +5194,14 @@
       </p:cxnSp>
       <p:sp>
         <p:nvSpPr>
-          <p:cNvPr id="24" name="TextBox 23"/>
+          <p:cNvPr id="28" name="TextBox 27"/>
           <p:cNvSpPr txBox="1"/>
           <p:nvPr/>
         </p:nvSpPr>
         <p:spPr>
           <a:xfrm>
-            <a:off x="411480" y="5806440"/>
-            <a:ext cx="11368735" cy="822960"/>
+            <a:off x="411480" y="5897880"/>
+            <a:ext cx="11368735" cy="777240"/>
           </a:xfrm>
           <a:prstGeom prst="rect">
             <a:avLst/>
@@ -4951,13 +5220,13 @@
               </a:lnSpc>
             </a:pPr>
             <a:r>
-              <a:rPr sz="1400" b="0">
+              <a:rPr sz="1350" b="0">
                 <a:solidFill>
                   <a:srgbClr val="616161"/>
                 </a:solidFill>
                 <a:latin typeface="Calibri"/>
               </a:rPr>
-              <a:t>Flow: the car starting triggers the app  →  the phone records the drive  →  the backend converts driving data into emission estimates and checks them against the car's baseline  →  the owner sees records, trends and service alerts.</a:t>
+              <a:t>Every figure is anchored to measured fuel: litres from payments / the car itself → CO2 by fixed combustion chemistry (1 L petrol = 2.31 kg CO2) → the driving model only interpolates between measurements and is continuously calibrated against them.</a:t>
             </a:r>
           </a:p>
         </p:txBody>
@@ -9050,6 +9319,745 @@
 </p:sld>
 </file>
 
+<file path=ppt/slides/slide9.xml><?xml version="1.0" encoding="utf-8"?>
+<p:sld xmlns:a="http://schemas.openxmlformats.org/drawingml/2006/main" xmlns:p="http://schemas.openxmlformats.org/presentationml/2006/main" xmlns:r="http://schemas.openxmlformats.org/officeDocument/2006/relationships">
+  <p:cSld>
+    <p:spTree>
+      <p:nvGrpSpPr>
+        <p:cNvPr id="1" name=""/>
+        <p:cNvGrpSpPr/>
+        <p:nvPr/>
+      </p:nvGrpSpPr>
+      <p:grpSpPr/>
+      <p:sp>
+        <p:nvSpPr>
+          <p:cNvPr id="2" name="Rectangle 1"/>
+          <p:cNvSpPr/>
+          <p:nvPr/>
+        </p:nvSpPr>
+        <p:spPr>
+          <a:xfrm>
+            <a:off x="0" y="0"/>
+            <a:ext cx="12191695" cy="914400"/>
+          </a:xfrm>
+          <a:prstGeom prst="rect">
+            <a:avLst/>
+          </a:prstGeom>
+          <a:solidFill>
+            <a:srgbClr val="1B5E20"/>
+          </a:solidFill>
+          <a:ln>
+            <a:noFill/>
+          </a:ln>
+          <a:effectLst/>
+        </p:spPr>
+        <p:style>
+          <a:lnRef idx="1">
+            <a:schemeClr val="accent1"/>
+          </a:lnRef>
+          <a:fillRef idx="3">
+            <a:schemeClr val="accent1"/>
+          </a:fillRef>
+          <a:effectRef idx="2">
+            <a:schemeClr val="accent1"/>
+          </a:effectRef>
+          <a:fontRef idx="minor">
+            <a:schemeClr val="lt1"/>
+          </a:fontRef>
+        </p:style>
+        <p:txBody>
+          <a:bodyPr rtlCol="0" anchor="ctr"/>
+          <a:lstStyle/>
+          <a:p>
+            <a:pPr algn="ctr"/>
+          </a:p>
+        </p:txBody>
+      </p:sp>
+      <p:sp>
+        <p:nvSpPr>
+          <p:cNvPr id="3" name="TextBox 2"/>
+          <p:cNvSpPr txBox="1"/>
+          <p:nvPr/>
+        </p:nvSpPr>
+        <p:spPr>
+          <a:xfrm>
+            <a:off x="502920" y="118872"/>
+            <a:ext cx="11185855" cy="685800"/>
+          </a:xfrm>
+          <a:prstGeom prst="rect">
+            <a:avLst/>
+          </a:prstGeom>
+          <a:noFill/>
+        </p:spPr>
+        <p:txBody>
+          <a:bodyPr wrap="square" anchor="ctr">
+            <a:spAutoFit/>
+          </a:bodyPr>
+          <a:lstStyle/>
+          <a:p>
+            <a:pPr algn="l">
+              <a:lnSpc>
+                <a:spcPct val="100000"/>
+              </a:lnSpc>
+            </a:pPr>
+            <a:r>
+              <a:rPr sz="3000" b="1">
+                <a:solidFill>
+                  <a:srgbClr val="FFFFFF"/>
+                </a:solidFill>
+                <a:latin typeface="Calibri"/>
+              </a:rPr>
+              <a:t>Data Captures Itself — No Typing, No Habit Change</a:t>
+            </a:r>
+          </a:p>
+        </p:txBody>
+      </p:sp>
+      <p:sp>
+        <p:nvSpPr>
+          <p:cNvPr id="4" name="Rectangle 3"/>
+          <p:cNvSpPr/>
+          <p:nvPr/>
+        </p:nvSpPr>
+        <p:spPr>
+          <a:xfrm>
+            <a:off x="0" y="914400"/>
+            <a:ext cx="12191695" cy="54864"/>
+          </a:xfrm>
+          <a:prstGeom prst="rect">
+            <a:avLst/>
+          </a:prstGeom>
+          <a:solidFill>
+            <a:srgbClr val="F9A825"/>
+          </a:solidFill>
+          <a:ln>
+            <a:noFill/>
+          </a:ln>
+          <a:effectLst/>
+        </p:spPr>
+        <p:style>
+          <a:lnRef idx="1">
+            <a:schemeClr val="accent1"/>
+          </a:lnRef>
+          <a:fillRef idx="3">
+            <a:schemeClr val="accent1"/>
+          </a:fillRef>
+          <a:effectRef idx="2">
+            <a:schemeClr val="accent1"/>
+          </a:effectRef>
+          <a:fontRef idx="minor">
+            <a:schemeClr val="lt1"/>
+          </a:fontRef>
+        </p:style>
+        <p:txBody>
+          <a:bodyPr rtlCol="0" anchor="ctr"/>
+          <a:lstStyle/>
+          <a:p>
+            <a:pPr algn="ctr"/>
+          </a:p>
+        </p:txBody>
+      </p:sp>
+      <p:graphicFrame>
+        <p:nvGraphicFramePr>
+          <p:cNvPr id="5" name="Table 4"/>
+          <p:cNvGraphicFramePr>
+            <a:graphicFrameLocks noGrp="1"/>
+          </p:cNvGraphicFramePr>
+          <p:nvPr/>
+        </p:nvGraphicFramePr>
+        <p:xfrm>
+          <a:off x="411480" y="1234440"/>
+          <a:ext cx="11365992" cy="3886200"/>
+        </p:xfrm>
+        <a:graphic>
+          <a:graphicData uri="http://schemas.openxmlformats.org/drawingml/2006/table">
+            <a:tbl>
+              <a:tblPr firstRow="1" bandRow="1">
+                <a:tableStyleId>{5C22544A-7EE6-4342-B048-85BDC9FD1C3A}</a:tableStyleId>
+              </a:tblPr>
+              <a:tblGrid>
+                <a:gridCol w="2651760"/>
+                <a:gridCol w="2926080"/>
+                <a:gridCol w="3291840"/>
+                <a:gridCol w="2496312"/>
+              </a:tblGrid>
+              <a:tr h="457200">
+                <a:tc>
+                  <a:txBody>
+                    <a:bodyPr wrap="square"/>
+                    <a:lstStyle/>
+                    <a:p>
+                      <a:r>
+                        <a:rPr sz="1400" b="1">
+                          <a:solidFill>
+                            <a:srgbClr val="FFFFFF"/>
+                          </a:solidFill>
+                          <a:latin typeface="Calibri"/>
+                        </a:rPr>
+                        <a:t>Tier</a:t>
+                      </a:r>
+                    </a:p>
+                  </a:txBody>
+                  <a:tcPr marL="82296" marR="82296" anchor="ctr">
+                    <a:solidFill>
+                      <a:srgbClr val="1B5E20"/>
+                    </a:solidFill>
+                  </a:tcPr>
+                </a:tc>
+                <a:tc>
+                  <a:txBody>
+                    <a:bodyPr wrap="square"/>
+                    <a:lstStyle/>
+                    <a:p>
+                      <a:r>
+                        <a:rPr sz="1400" b="1">
+                          <a:solidFill>
+                            <a:srgbClr val="FFFFFF"/>
+                          </a:solidFill>
+                          <a:latin typeface="Calibri"/>
+                        </a:rPr>
+                        <a:t>Odometer</a:t>
+                      </a:r>
+                    </a:p>
+                  </a:txBody>
+                  <a:tcPr marL="82296" marR="82296" anchor="ctr">
+                    <a:solidFill>
+                      <a:srgbClr val="1B5E20"/>
+                    </a:solidFill>
+                  </a:tcPr>
+                </a:tc>
+                <a:tc>
+                  <a:txBody>
+                    <a:bodyPr wrap="square"/>
+                    <a:lstStyle/>
+                    <a:p>
+                      <a:r>
+                        <a:rPr sz="1400" b="1">
+                          <a:solidFill>
+                            <a:srgbClr val="FFFFFF"/>
+                          </a:solidFill>
+                          <a:latin typeface="Calibri"/>
+                        </a:rPr>
+                        <a:t>Fuel (litres)</a:t>
+                      </a:r>
+                    </a:p>
+                  </a:txBody>
+                  <a:tcPr marL="82296" marR="82296" anchor="ctr">
+                    <a:solidFill>
+                      <a:srgbClr val="1B5E20"/>
+                    </a:solidFill>
+                  </a:tcPr>
+                </a:tc>
+                <a:tc>
+                  <a:txBody>
+                    <a:bodyPr wrap="square"/>
+                    <a:lstStyle/>
+                    <a:p>
+                      <a:r>
+                        <a:rPr sz="1400" b="1">
+                          <a:solidFill>
+                            <a:srgbClr val="FFFFFF"/>
+                          </a:solidFill>
+                          <a:latin typeface="Calibri"/>
+                        </a:rPr>
+                        <a:t>Hardware needed</a:t>
+                      </a:r>
+                    </a:p>
+                  </a:txBody>
+                  <a:tcPr marL="82296" marR="82296" anchor="ctr">
+                    <a:solidFill>
+                      <a:srgbClr val="1B5E20"/>
+                    </a:solidFill>
+                  </a:tcPr>
+                </a:tc>
+              </a:tr>
+              <a:tr h="1143000">
+                <a:tc>
+                  <a:txBody>
+                    <a:bodyPr wrap="square"/>
+                    <a:lstStyle/>
+                    <a:p>
+                      <a:r>
+                        <a:rPr sz="1250" b="1">
+                          <a:solidFill>
+                            <a:srgbClr val="1B5E20"/>
+                          </a:solidFill>
+                          <a:latin typeface="Calibri"/>
+                        </a:rPr>
+                        <a:t>Zero-hardware</a:t>
+                      </a:r>
+                    </a:p>
+                    <a:p>
+                      <a:r>
+                        <a:rPr sz="1250" b="0">
+                          <a:solidFill>
+                            <a:srgbClr val="1B5E20"/>
+                          </a:solidFill>
+                          <a:latin typeface="Calibri"/>
+                        </a:rPr>
+                        <a:t>(every car on the road)</a:t>
+                      </a:r>
+                    </a:p>
+                  </a:txBody>
+                  <a:tcPr marL="82296" marR="82296" anchor="ctr">
+                    <a:solidFill>
+                      <a:srgbClr val="F1F8E9"/>
+                    </a:solidFill>
+                  </a:tcPr>
+                </a:tc>
+                <a:tc>
+                  <a:txBody>
+                    <a:bodyPr wrap="square"/>
+                    <a:lstStyle/>
+                    <a:p>
+                      <a:r>
+                        <a:rPr sz="1250" b="0">
+                          <a:solidFill>
+                            <a:srgbClr val="212121"/>
+                          </a:solidFill>
+                          <a:latin typeface="Calibri"/>
+                        </a:rPr>
+                        <a:t>Virtual odometer: set once,</a:t>
+                      </a:r>
+                    </a:p>
+                    <a:p>
+                      <a:r>
+                        <a:rPr sz="1250" b="0">
+                          <a:solidFill>
+                            <a:srgbClr val="212121"/>
+                          </a:solidFill>
+                          <a:latin typeface="Calibri"/>
+                        </a:rPr>
+                        <a:t>GPS advances it every trip</a:t>
+                      </a:r>
+                    </a:p>
+                  </a:txBody>
+                  <a:tcPr marL="82296" marR="82296" anchor="ctr">
+                    <a:solidFill>
+                      <a:srgbClr val="FFFFFF"/>
+                    </a:solidFill>
+                  </a:tcPr>
+                </a:tc>
+                <a:tc>
+                  <a:txBody>
+                    <a:bodyPr wrap="square"/>
+                    <a:lstStyle/>
+                    <a:p>
+                      <a:r>
+                        <a:rPr sz="1250" b="0">
+                          <a:solidFill>
+                            <a:srgbClr val="212121"/>
+                          </a:solidFill>
+                          <a:latin typeface="Calibri"/>
+                        </a:rPr>
+                        <a:t>Payment notifications (UPI/card)</a:t>
+                      </a:r>
+                    </a:p>
+                    <a:p>
+                      <a:r>
+                        <a:rPr sz="1250" b="0">
+                          <a:solidFill>
+                            <a:srgbClr val="212121"/>
+                          </a:solidFill>
+                          <a:latin typeface="Calibri"/>
+                        </a:rPr>
+                        <a:t>auto-convert to litres on-device</a:t>
+                      </a:r>
+                    </a:p>
+                  </a:txBody>
+                  <a:tcPr marL="82296" marR="82296" anchor="ctr">
+                    <a:solidFill>
+                      <a:srgbClr val="FFFFFF"/>
+                    </a:solidFill>
+                  </a:tcPr>
+                </a:tc>
+                <a:tc>
+                  <a:txBody>
+                    <a:bodyPr wrap="square"/>
+                    <a:lstStyle/>
+                    <a:p>
+                      <a:r>
+                        <a:rPr sz="1250" b="0">
+                          <a:solidFill>
+                            <a:srgbClr val="212121"/>
+                          </a:solidFill>
+                          <a:latin typeface="Calibri"/>
+                        </a:rPr>
+                        <a:t>None</a:t>
+                      </a:r>
+                    </a:p>
+                  </a:txBody>
+                  <a:tcPr marL="82296" marR="82296" anchor="ctr">
+                    <a:solidFill>
+                      <a:srgbClr val="FFFFFF"/>
+                    </a:solidFill>
+                  </a:tcPr>
+                </a:tc>
+              </a:tr>
+              <a:tr h="1143000">
+                <a:tc>
+                  <a:txBody>
+                    <a:bodyPr wrap="square"/>
+                    <a:lstStyle/>
+                    <a:p>
+                      <a:r>
+                        <a:rPr sz="1250" b="1">
+                          <a:solidFill>
+                            <a:srgbClr val="1B5E20"/>
+                          </a:solidFill>
+                          <a:latin typeface="Calibri"/>
+                        </a:rPr>
+                        <a:t>Connected car</a:t>
+                      </a:r>
+                    </a:p>
+                    <a:p>
+                      <a:r>
+                        <a:rPr sz="1250" b="0">
+                          <a:solidFill>
+                            <a:srgbClr val="1B5E20"/>
+                          </a:solidFill>
+                          <a:latin typeface="Calibri"/>
+                        </a:rPr>
+                        <a:t>(BlueLink, iRA, iSmart...)</a:t>
+                      </a:r>
+                    </a:p>
+                  </a:txBody>
+                  <a:tcPr marL="82296" marR="82296" anchor="ctr">
+                    <a:solidFill>
+                      <a:srgbClr val="F1F8E9"/>
+                    </a:solidFill>
+                  </a:tcPr>
+                </a:tc>
+                <a:tc>
+                  <a:txBody>
+                    <a:bodyPr wrap="square"/>
+                    <a:lstStyle/>
+                    <a:p>
+                      <a:r>
+                        <a:rPr sz="1250" b="0">
+                          <a:solidFill>
+                            <a:srgbClr val="212121"/>
+                          </a:solidFill>
+                          <a:latin typeface="Calibri"/>
+                        </a:rPr>
+                        <a:t>Exact reading from the</a:t>
+                      </a:r>
+                    </a:p>
+                    <a:p>
+                      <a:r>
+                        <a:rPr sz="1250" b="0">
+                          <a:solidFill>
+                            <a:srgbClr val="212121"/>
+                          </a:solidFill>
+                          <a:latin typeface="Calibri"/>
+                        </a:rPr>
+                        <a:t>manufacturer cloud</a:t>
+                      </a:r>
+                    </a:p>
+                  </a:txBody>
+                  <a:tcPr marL="82296" marR="82296" anchor="ctr">
+                    <a:solidFill>
+                      <a:srgbClr val="FFFFFF"/>
+                    </a:solidFill>
+                  </a:tcPr>
+                </a:tc>
+                <a:tc>
+                  <a:txBody>
+                    <a:bodyPr wrap="square"/>
+                    <a:lstStyle/>
+                    <a:p>
+                      <a:r>
+                        <a:rPr sz="1250" b="0">
+                          <a:solidFill>
+                            <a:srgbClr val="212121"/>
+                          </a:solidFill>
+                          <a:latin typeface="Calibri"/>
+                        </a:rPr>
+                        <a:t>Fuel-level changes reported</a:t>
+                      </a:r>
+                    </a:p>
+                    <a:p>
+                      <a:r>
+                        <a:rPr sz="1250" b="0">
+                          <a:solidFill>
+                            <a:srgbClr val="212121"/>
+                          </a:solidFill>
+                          <a:latin typeface="Calibri"/>
+                        </a:rPr>
+                        <a:t>by the car's built-in telematics</a:t>
+                      </a:r>
+                    </a:p>
+                  </a:txBody>
+                  <a:tcPr marL="82296" marR="82296" anchor="ctr">
+                    <a:solidFill>
+                      <a:srgbClr val="FFFFFF"/>
+                    </a:solidFill>
+                  </a:tcPr>
+                </a:tc>
+                <a:tc>
+                  <a:txBody>
+                    <a:bodyPr wrap="square"/>
+                    <a:lstStyle/>
+                    <a:p>
+                      <a:r>
+                        <a:rPr sz="1250" b="0">
+                          <a:solidFill>
+                            <a:srgbClr val="212121"/>
+                          </a:solidFill>
+                          <a:latin typeface="Calibri"/>
+                        </a:rPr>
+                        <a:t>None extra - factory TCU</a:t>
+                      </a:r>
+                    </a:p>
+                    <a:p>
+                      <a:r>
+                        <a:rPr sz="1250" b="0">
+                          <a:solidFill>
+                            <a:srgbClr val="212121"/>
+                          </a:solidFill>
+                          <a:latin typeface="Calibri"/>
+                        </a:rPr>
+                        <a:t>already in the car</a:t>
+                      </a:r>
+                    </a:p>
+                  </a:txBody>
+                  <a:tcPr marL="82296" marR="82296" anchor="ctr">
+                    <a:solidFill>
+                      <a:srgbClr val="FFFFFF"/>
+                    </a:solidFill>
+                  </a:tcPr>
+                </a:tc>
+              </a:tr>
+              <a:tr h="1143000">
+                <a:tc>
+                  <a:txBody>
+                    <a:bodyPr wrap="square"/>
+                    <a:lstStyle/>
+                    <a:p>
+                      <a:r>
+                        <a:rPr sz="1250" b="1">
+                          <a:solidFill>
+                            <a:srgbClr val="1B5E20"/>
+                          </a:solidFill>
+                          <a:latin typeface="Calibri"/>
+                        </a:rPr>
+                        <a:t>OBD pro tier</a:t>
+                      </a:r>
+                    </a:p>
+                    <a:p>
+                      <a:r>
+                        <a:rPr sz="1250" b="0">
+                          <a:solidFill>
+                            <a:srgbClr val="1B5E20"/>
+                          </a:solidFill>
+                          <a:latin typeface="Calibri"/>
+                        </a:rPr>
+                        <a:t>(optional)</a:t>
+                      </a:r>
+                    </a:p>
+                  </a:txBody>
+                  <a:tcPr marL="82296" marR="82296" anchor="ctr">
+                    <a:solidFill>
+                      <a:srgbClr val="F1F8E9"/>
+                    </a:solidFill>
+                  </a:tcPr>
+                </a:tc>
+                <a:tc>
+                  <a:txBody>
+                    <a:bodyPr wrap="square"/>
+                    <a:lstStyle/>
+                    <a:p>
+                      <a:r>
+                        <a:rPr sz="1250" b="0">
+                          <a:solidFill>
+                            <a:srgbClr val="212121"/>
+                          </a:solidFill>
+                          <a:latin typeface="Calibri"/>
+                        </a:rPr>
+                        <a:t>True ECU odometer (PID A6),</a:t>
+                      </a:r>
+                    </a:p>
+                    <a:p>
+                      <a:r>
+                        <a:rPr sz="1250" b="0">
+                          <a:solidFill>
+                            <a:srgbClr val="212121"/>
+                          </a:solidFill>
+                          <a:latin typeface="Calibri"/>
+                        </a:rPr>
+                        <a:t>auto-corrects GPS drift</a:t>
+                      </a:r>
+                    </a:p>
+                  </a:txBody>
+                  <a:tcPr marL="82296" marR="82296" anchor="ctr">
+                    <a:solidFill>
+                      <a:srgbClr val="FFFFFF"/>
+                    </a:solidFill>
+                  </a:tcPr>
+                </a:tc>
+                <a:tc>
+                  <a:txBody>
+                    <a:bodyPr wrap="square"/>
+                    <a:lstStyle/>
+                    <a:p>
+                      <a:r>
+                        <a:rPr sz="1250" b="0">
+                          <a:solidFill>
+                            <a:srgbClr val="212121"/>
+                          </a:solidFill>
+                          <a:latin typeface="Calibri"/>
+                        </a:rPr>
+                        <a:t>Live fuel flow measured from</a:t>
+                      </a:r>
+                    </a:p>
+                    <a:p>
+                      <a:r>
+                        <a:rPr sz="1250" b="0">
+                          <a:solidFill>
+                            <a:srgbClr val="212121"/>
+                          </a:solidFill>
+                          <a:latin typeface="Calibri"/>
+                        </a:rPr>
+                        <a:t>the engine's airflow sensor</a:t>
+                      </a:r>
+                    </a:p>
+                  </a:txBody>
+                  <a:tcPr marL="82296" marR="82296" anchor="ctr">
+                    <a:solidFill>
+                      <a:srgbClr val="FFFFFF"/>
+                    </a:solidFill>
+                  </a:tcPr>
+                </a:tc>
+                <a:tc>
+                  <a:txBody>
+                    <a:bodyPr wrap="square"/>
+                    <a:lstStyle/>
+                    <a:p>
+                      <a:r>
+                        <a:rPr sz="1250" b="0">
+                          <a:solidFill>
+                            <a:srgbClr val="212121"/>
+                          </a:solidFill>
+                          <a:latin typeface="Calibri"/>
+                        </a:rPr>
+                        <a:t>₹500 ELM327 adapter</a:t>
+                      </a:r>
+                    </a:p>
+                    <a:p>
+                      <a:r>
+                        <a:rPr sz="1250" b="0">
+                          <a:solidFill>
+                            <a:srgbClr val="212121"/>
+                          </a:solidFill>
+                          <a:latin typeface="Calibri"/>
+                        </a:rPr>
+                        <a:t>in the OBD port</a:t>
+                      </a:r>
+                    </a:p>
+                  </a:txBody>
+                  <a:tcPr marL="82296" marR="82296" anchor="ctr">
+                    <a:solidFill>
+                      <a:srgbClr val="FFFFFF"/>
+                    </a:solidFill>
+                  </a:tcPr>
+                </a:tc>
+              </a:tr>
+            </a:tbl>
+          </a:graphicData>
+        </a:graphic>
+      </p:graphicFrame>
+      <p:sp>
+        <p:nvSpPr>
+          <p:cNvPr id="6" name="Rounded Rectangle 5"/>
+          <p:cNvSpPr/>
+          <p:nvPr/>
+        </p:nvSpPr>
+        <p:spPr>
+          <a:xfrm>
+            <a:off x="411480" y="5486400"/>
+            <a:ext cx="11368735" cy="914400"/>
+          </a:xfrm>
+          <a:prstGeom prst="roundRect">
+            <a:avLst/>
+          </a:prstGeom>
+          <a:solidFill>
+            <a:srgbClr val="F1F8E9"/>
+          </a:solidFill>
+          <a:ln w="12700">
+            <a:solidFill>
+              <a:srgbClr val="43A047"/>
+            </a:solidFill>
+          </a:ln>
+          <a:effectLst/>
+        </p:spPr>
+        <p:style>
+          <a:lnRef idx="1">
+            <a:schemeClr val="accent1"/>
+          </a:lnRef>
+          <a:fillRef idx="3">
+            <a:schemeClr val="accent1"/>
+          </a:fillRef>
+          <a:effectRef idx="2">
+            <a:schemeClr val="accent1"/>
+          </a:effectRef>
+          <a:fontRef idx="minor">
+            <a:schemeClr val="lt1"/>
+          </a:fontRef>
+        </p:style>
+        <p:txBody>
+          <a:bodyPr rtlCol="0" anchor="ctr"/>
+          <a:lstStyle/>
+          <a:p>
+            <a:pPr algn="ctr"/>
+          </a:p>
+        </p:txBody>
+      </p:sp>
+      <p:sp>
+        <p:nvSpPr>
+          <p:cNvPr id="7" name="TextBox 6"/>
+          <p:cNvSpPr txBox="1"/>
+          <p:nvPr/>
+        </p:nvSpPr>
+        <p:spPr>
+          <a:xfrm>
+            <a:off x="640080" y="5596128"/>
+            <a:ext cx="10911535" cy="731520"/>
+          </a:xfrm>
+          <a:prstGeom prst="rect">
+            <a:avLst/>
+          </a:prstGeom>
+          <a:noFill/>
+        </p:spPr>
+        <p:txBody>
+          <a:bodyPr wrap="square" anchor="ctr">
+            <a:spAutoFit/>
+          </a:bodyPr>
+          <a:lstStyle/>
+          <a:p>
+            <a:pPr algn="ctr">
+              <a:lnSpc>
+                <a:spcPct val="120000"/>
+              </a:lnSpc>
+            </a:pPr>
+            <a:r>
+              <a:rPr sz="1400" b="0">
+                <a:solidFill>
+                  <a:srgbClr val="1B5E20"/>
+                </a:solidFill>
+                <a:latin typeface="Calibri"/>
+              </a:rPr>
+              <a:t>Trips record themselves (car Bluetooth) · odometer tracks itself · fill-ups log themselves from payment alerts · refuel stops are auto-detected from GPS. The only manual case left: paying cash at the pump.</a:t>
+            </a:r>
+          </a:p>
+        </p:txBody>
+      </p:sp>
+    </p:spTree>
+  </p:cSld>
+  <p:clrMapOvr>
+    <a:masterClrMapping/>
+  </p:clrMapOvr>
+</p:sld>
+</file>
+
 <file path=ppt/theme/theme1.xml><?xml version="1.0" encoding="utf-8"?>
 <a:theme xmlns:a="http://schemas.openxmlformats.org/drawingml/2006/main" name="Office Theme">
   <a:themeElements>

</xml_diff>